<commit_message>
feat: ActionCommand 장착 UI 구현 및 시스템 통합
feat: ActionCommand 장착 UI 구현 및 시스템 통합

- UI: ActionCommandEquipUI, SlotUI, DetailPanel 구현
- 시스템: MainMenuManager, GameInputManager 추가
- 개선: Database 로딩 안정성, DatabaseKey List 지원
- 수정: EquippedSwordArtStyleUI 표시 문제, 이벤트 타이밍 문제 해결

작업 시간: 8시간
</commit_message>
<xml_diff>
--- a/Docs/Design/UI/UI기획_인벤토리와 검술 설정.pptx
+++ b/Docs/Design/UI/UI기획_인벤토리와 검술 설정.pptx
@@ -267,7 +267,7 @@
           <a:p>
             <a:fld id="{0F9DA38A-AD18-4514-81BD-890B8AE83131}" type="datetimeFigureOut">
               <a:rPr lang="ko-KR" altLang="en-US" smtClean="0"/>
-              <a:t>2025-10-29</a:t>
+              <a:t>2025-10-30</a:t>
             </a:fld>
             <a:endParaRPr lang="ko-KR" altLang="en-US"/>
           </a:p>
@@ -465,7 +465,7 @@
           <a:p>
             <a:fld id="{0F9DA38A-AD18-4514-81BD-890B8AE83131}" type="datetimeFigureOut">
               <a:rPr lang="ko-KR" altLang="en-US" smtClean="0"/>
-              <a:t>2025-10-29</a:t>
+              <a:t>2025-10-30</a:t>
             </a:fld>
             <a:endParaRPr lang="ko-KR" altLang="en-US"/>
           </a:p>
@@ -673,7 +673,7 @@
           <a:p>
             <a:fld id="{0F9DA38A-AD18-4514-81BD-890B8AE83131}" type="datetimeFigureOut">
               <a:rPr lang="ko-KR" altLang="en-US" smtClean="0"/>
-              <a:t>2025-10-29</a:t>
+              <a:t>2025-10-30</a:t>
             </a:fld>
             <a:endParaRPr lang="ko-KR" altLang="en-US"/>
           </a:p>
@@ -871,7 +871,7 @@
           <a:p>
             <a:fld id="{0F9DA38A-AD18-4514-81BD-890B8AE83131}" type="datetimeFigureOut">
               <a:rPr lang="ko-KR" altLang="en-US" smtClean="0"/>
-              <a:t>2025-10-29</a:t>
+              <a:t>2025-10-30</a:t>
             </a:fld>
             <a:endParaRPr lang="ko-KR" altLang="en-US"/>
           </a:p>
@@ -1146,7 +1146,7 @@
           <a:p>
             <a:fld id="{0F9DA38A-AD18-4514-81BD-890B8AE83131}" type="datetimeFigureOut">
               <a:rPr lang="ko-KR" altLang="en-US" smtClean="0"/>
-              <a:t>2025-10-29</a:t>
+              <a:t>2025-10-30</a:t>
             </a:fld>
             <a:endParaRPr lang="ko-KR" altLang="en-US"/>
           </a:p>
@@ -1411,7 +1411,7 @@
           <a:p>
             <a:fld id="{0F9DA38A-AD18-4514-81BD-890B8AE83131}" type="datetimeFigureOut">
               <a:rPr lang="ko-KR" altLang="en-US" smtClean="0"/>
-              <a:t>2025-10-29</a:t>
+              <a:t>2025-10-30</a:t>
             </a:fld>
             <a:endParaRPr lang="ko-KR" altLang="en-US"/>
           </a:p>
@@ -1823,7 +1823,7 @@
           <a:p>
             <a:fld id="{0F9DA38A-AD18-4514-81BD-890B8AE83131}" type="datetimeFigureOut">
               <a:rPr lang="ko-KR" altLang="en-US" smtClean="0"/>
-              <a:t>2025-10-29</a:t>
+              <a:t>2025-10-30</a:t>
             </a:fld>
             <a:endParaRPr lang="ko-KR" altLang="en-US"/>
           </a:p>
@@ -1964,7 +1964,7 @@
           <a:p>
             <a:fld id="{0F9DA38A-AD18-4514-81BD-890B8AE83131}" type="datetimeFigureOut">
               <a:rPr lang="ko-KR" altLang="en-US" smtClean="0"/>
-              <a:t>2025-10-29</a:t>
+              <a:t>2025-10-30</a:t>
             </a:fld>
             <a:endParaRPr lang="ko-KR" altLang="en-US"/>
           </a:p>
@@ -2077,7 +2077,7 @@
           <a:p>
             <a:fld id="{0F9DA38A-AD18-4514-81BD-890B8AE83131}" type="datetimeFigureOut">
               <a:rPr lang="ko-KR" altLang="en-US" smtClean="0"/>
-              <a:t>2025-10-29</a:t>
+              <a:t>2025-10-30</a:t>
             </a:fld>
             <a:endParaRPr lang="ko-KR" altLang="en-US"/>
           </a:p>
@@ -2388,7 +2388,7 @@
           <a:p>
             <a:fld id="{0F9DA38A-AD18-4514-81BD-890B8AE83131}" type="datetimeFigureOut">
               <a:rPr lang="ko-KR" altLang="en-US" smtClean="0"/>
-              <a:t>2025-10-29</a:t>
+              <a:t>2025-10-30</a:t>
             </a:fld>
             <a:endParaRPr lang="ko-KR" altLang="en-US"/>
           </a:p>
@@ -2676,7 +2676,7 @@
           <a:p>
             <a:fld id="{0F9DA38A-AD18-4514-81BD-890B8AE83131}" type="datetimeFigureOut">
               <a:rPr lang="ko-KR" altLang="en-US" smtClean="0"/>
-              <a:t>2025-10-29</a:t>
+              <a:t>2025-10-30</a:t>
             </a:fld>
             <a:endParaRPr lang="ko-KR" altLang="en-US"/>
           </a:p>
@@ -2917,7 +2917,7 @@
           <a:p>
             <a:fld id="{0F9DA38A-AD18-4514-81BD-890B8AE83131}" type="datetimeFigureOut">
               <a:rPr lang="ko-KR" altLang="en-US" smtClean="0"/>
-              <a:t>2025-10-29</a:t>
+              <a:t>2025-10-30</a:t>
             </a:fld>
             <a:endParaRPr lang="ko-KR" altLang="en-US"/>
           </a:p>

</xml_diff>